<commit_message>
File dump - Fall 2025 including Orange files
</commit_message>
<xml_diff>
--- a/Slides/Discussions/Recidivism Questions - ProPublica.pptx
+++ b/Slides/Discussions/Recidivism Questions - ProPublica.pptx
@@ -5,15 +5,14 @@
     <p:sldMasterId id="2147483660" r:id="rId1"/>
   </p:sldMasterIdLst>
   <p:notesMasterIdLst>
-    <p:notesMasterId r:id="rId6"/>
+    <p:notesMasterId r:id="rId5"/>
   </p:notesMasterIdLst>
   <p:sldIdLst>
     <p:sldId id="257" r:id="rId2"/>
     <p:sldId id="258" r:id="rId3"/>
     <p:sldId id="259" r:id="rId4"/>
-    <p:sldId id="260" r:id="rId5"/>
   </p:sldIdLst>
-  <p:sldSz cx="9144000" cy="6858000" type="screen4x3"/>
+  <p:sldSz cx="12192000" cy="6858000"/>
   <p:notesSz cx="6858000" cy="9144000"/>
   <p:defaultTextStyle>
     <a:defPPr>
@@ -250,7 +249,7 @@
           <a:p>
             <a:fld id="{0813ED7A-E0CC-A14D-8702-3DBB30C4345D}" type="datetimeFigureOut">
               <a:rPr lang="en-US" smtClean="0"/>
-              <a:t>10/24/24</a:t>
+              <a:t>10/29/25</a:t>
             </a:fld>
             <a:endParaRPr lang="en-US"/>
           </a:p>
@@ -268,8 +267,8 @@
         </p:nvSpPr>
         <p:spPr>
           <a:xfrm>
-            <a:off x="1371600" y="1143000"/>
-            <a:ext cx="4114800" cy="3086100"/>
+            <a:off x="685800" y="1143000"/>
+            <a:ext cx="5486400" cy="3086100"/>
           </a:xfrm>
           <a:prstGeom prst="rect">
             <a:avLst/>
@@ -544,7 +543,12 @@
             <p:ph type="sldImg"/>
           </p:nvPr>
         </p:nvSpPr>
-        <p:spPr/>
+        <p:spPr>
+          <a:xfrm>
+            <a:off x="685800" y="1143000"/>
+            <a:ext cx="5486400" cy="3086100"/>
+          </a:xfrm>
+        </p:spPr>
       </p:sp>
       <p:sp>
         <p:nvSpPr>
@@ -572,6 +576,23 @@
           <a:p>
             <a:r>
               <a:rPr lang="en-US" dirty="0"/>
+              <a:t>Article: “Only 20 percent of the people predicted to commit violent crime went on to do so” – what is that?  Also </a:t>
+            </a:r>
+            <a:r>
+              <a:rPr lang="en-US" dirty="0" err="1"/>
+              <a:t>followup</a:t>
+            </a:r>
+            <a:r>
+              <a:rPr lang="en-US" dirty="0"/>
+              <a:t> accuracy statement</a:t>
+            </a:r>
+          </a:p>
+          <a:p>
+            <a:endParaRPr lang="en-US" dirty="0"/>
+          </a:p>
+          <a:p>
+            <a:r>
+              <a:rPr lang="en-US" dirty="0"/>
               <a:t>Using traits like intelligence, introversion and extroversion for to build assessment scores. </a:t>
             </a:r>
           </a:p>
@@ -583,6 +604,47 @@
               <a:rPr lang="en-US" dirty="0"/>
               <a:t>The problem is that the score is solely being used, instead of being taken into account with other factors. </a:t>
             </a:r>
+          </a:p>
+          <a:p>
+            <a:endParaRPr lang="en-US" dirty="0"/>
+          </a:p>
+          <a:p>
+            <a:pPr marL="0" marR="0" lvl="0" indent="0" algn="l" defTabSz="914400" rtl="0" eaLnBrk="1" fontAlgn="auto" latinLnBrk="0" hangingPunct="1">
+              <a:lnSpc>
+                <a:spcPct val="100000"/>
+              </a:lnSpc>
+              <a:spcBef>
+                <a:spcPts val="0"/>
+              </a:spcBef>
+              <a:spcAft>
+                <a:spcPts val="0"/>
+              </a:spcAft>
+              <a:buClrTx/>
+              <a:buSzTx/>
+              <a:buFontTx/>
+              <a:buNone/>
+              <a:tabLst/>
+              <a:defRPr/>
+            </a:pPr>
+            <a:r>
+              <a:rPr lang="en-US" dirty="0"/>
+              <a:t>Do you think adding race as an explicit feature would create more racial disparity, or allow us to correct for racial disparity? </a:t>
+            </a:r>
+          </a:p>
+          <a:p>
+            <a:endParaRPr lang="en-US" dirty="0"/>
+          </a:p>
+          <a:p>
+            <a:r>
+              <a:rPr lang="en-US" dirty="0"/>
+              <a:t>Can you relate this to PM decisions…rolling out cell towers – model says to place them in rich areas</a:t>
+            </a:r>
+          </a:p>
+          <a:p>
+            <a:endParaRPr lang="en-US" dirty="0"/>
+          </a:p>
+          <a:p>
+            <a:endParaRPr lang="en-US" dirty="0"/>
           </a:p>
         </p:txBody>
       </p:sp>
@@ -649,7 +711,12 @@
             <p:ph type="sldImg"/>
           </p:nvPr>
         </p:nvSpPr>
-        <p:spPr/>
+        <p:spPr>
+          <a:xfrm>
+            <a:off x="685800" y="1143000"/>
+            <a:ext cx="5486400" cy="3086100"/>
+          </a:xfrm>
+        </p:spPr>
       </p:sp>
       <p:sp>
         <p:nvSpPr>
@@ -674,7 +741,57 @@
           <a:p>
             <a:r>
               <a:rPr lang="en-US" dirty="0"/>
-              <a:t>FPR measures FP related to TN</a:t>
+              <a:t>Precision Black = 1369/2174 = 63% recall=72</a:t>
+            </a:r>
+          </a:p>
+          <a:p>
+            <a:r>
+              <a:rPr lang="en-US" dirty="0"/>
+              <a:t>Precision White = 59% = 505/854 recall=52</a:t>
+            </a:r>
+          </a:p>
+          <a:p>
+            <a:endParaRPr lang="en-US" dirty="0"/>
+          </a:p>
+          <a:p>
+            <a:r>
+              <a:rPr lang="en-US" dirty="0"/>
+              <a:t>FPR = 805 / (805+990) measures FP related to TN (of those that are truly negative)</a:t>
+            </a:r>
+          </a:p>
+          <a:p>
+            <a:r>
+              <a:rPr lang="en-US" dirty="0" err="1"/>
+              <a:t>Compas</a:t>
+            </a:r>
+            <a:r>
+              <a:rPr lang="en-US" dirty="0"/>
+              <a:t> is saying that a False </a:t>
+            </a:r>
+            <a:r>
+              <a:rPr lang="en-US" dirty="0" err="1"/>
+              <a:t>Postive</a:t>
+            </a:r>
+            <a:r>
+              <a:rPr lang="en-US" dirty="0"/>
+              <a:t>  </a:t>
+            </a:r>
+          </a:p>
+          <a:p>
+            <a:endParaRPr lang="en-US" dirty="0"/>
+          </a:p>
+          <a:p>
+            <a:r>
+              <a:rPr lang="en-US" dirty="0"/>
+              <a:t>The model is more likely to correctly predict </a:t>
+            </a:r>
+            <a:r>
+              <a:rPr lang="en-US" dirty="0" err="1"/>
+              <a:t>recid</a:t>
+            </a:r>
+            <a:r>
+              <a:rPr lang="en-US" dirty="0"/>
+              <a:t> for blacks, but it is also more likely to incorrectly predict recidivism for blacks – because it is more like to predict pos for blacks overall! </a:t>
             </a:r>
           </a:p>
           <a:p>
@@ -684,6 +801,23 @@
             <a:r>
               <a:rPr lang="en-US" dirty="0"/>
               <a:t>For those that truly did not re-offend, blacks were more likely to be predicted as offenders</a:t>
+            </a:r>
+          </a:p>
+          <a:p>
+            <a:endParaRPr lang="en-US" dirty="0"/>
+          </a:p>
+          <a:p>
+            <a:r>
+              <a:rPr lang="en-US" dirty="0"/>
+              <a:t>This is because of the overall </a:t>
+            </a:r>
+            <a:r>
+              <a:rPr lang="en-US" dirty="0" err="1"/>
+              <a:t>baserate</a:t>
+            </a:r>
+            <a:r>
+              <a:rPr lang="en-US" dirty="0"/>
+              <a:t> of black recidivism.  </a:t>
             </a:r>
           </a:p>
           <a:p>
@@ -759,8 +893,8 @@
         </p:nvSpPr>
         <p:spPr>
           <a:xfrm>
-            <a:off x="457200" y="278640"/>
-            <a:ext cx="7772400" cy="1470025"/>
+            <a:off x="609600" y="278640"/>
+            <a:ext cx="10363200" cy="1470025"/>
           </a:xfrm>
         </p:spPr>
         <p:txBody>
@@ -794,8 +928,8 @@
         </p:nvSpPr>
         <p:spPr>
           <a:xfrm>
-            <a:off x="1143000" y="2139536"/>
-            <a:ext cx="6400800" cy="1752600"/>
+            <a:off x="1524000" y="2139536"/>
+            <a:ext cx="8534400" cy="1752600"/>
           </a:xfrm>
         </p:spPr>
         <p:txBody>
@@ -884,7 +1018,7 @@
           <a:p>
             <a:fld id="{59F43C82-9B9B-AC4F-98CD-0ADC587116F3}" type="datetime1">
               <a:rPr lang="en-US" smtClean="0"/>
-              <a:t>10/24/24</a:t>
+              <a:t>10/29/25</a:t>
             </a:fld>
             <a:endParaRPr lang="en-US"/>
           </a:p>
@@ -966,8 +1100,8 @@
         </p:blipFill>
         <p:spPr>
           <a:xfrm>
-            <a:off x="1931504" y="3429000"/>
-            <a:ext cx="4823791" cy="2717402"/>
+            <a:off x="2575339" y="3429000"/>
+            <a:ext cx="6431721" cy="2717402"/>
           </a:xfrm>
           <a:prstGeom prst="rect">
             <a:avLst/>
@@ -1100,7 +1234,7 @@
           <a:p>
             <a:fld id="{F1178AE4-2A10-5F42-AC8C-4BD01A79A0D1}" type="datetime1">
               <a:rPr lang="en-US" smtClean="0"/>
-              <a:t>10/24/24</a:t>
+              <a:t>10/29/25</a:t>
             </a:fld>
             <a:endParaRPr lang="en-US"/>
           </a:p>
@@ -1202,8 +1336,8 @@
         </p:nvSpPr>
         <p:spPr>
           <a:xfrm>
-            <a:off x="6629400" y="274639"/>
-            <a:ext cx="2057400" cy="5851525"/>
+            <a:off x="8839200" y="274639"/>
+            <a:ext cx="2743200" cy="5851525"/>
           </a:xfrm>
         </p:spPr>
         <p:txBody>
@@ -1229,8 +1363,8 @@
         </p:nvSpPr>
         <p:spPr>
           <a:xfrm>
-            <a:off x="457200" y="274639"/>
-            <a:ext cx="6019800" cy="5851525"/>
+            <a:off x="609600" y="274639"/>
+            <a:ext cx="8026400" cy="5851525"/>
           </a:xfrm>
         </p:spPr>
         <p:txBody>
@@ -1296,7 +1430,7 @@
           <a:p>
             <a:fld id="{E675C519-8308-2748-8B0B-F7B055AE4297}" type="datetime1">
               <a:rPr lang="en-US" smtClean="0"/>
-              <a:t>10/24/24</a:t>
+              <a:t>10/29/25</a:t>
             </a:fld>
             <a:endParaRPr lang="en-US"/>
           </a:p>
@@ -1398,8 +1532,8 @@
         </p:nvSpPr>
         <p:spPr>
           <a:xfrm>
-            <a:off x="457200" y="274638"/>
-            <a:ext cx="8229600" cy="1143000"/>
+            <a:off x="609600" y="274638"/>
+            <a:ext cx="10972800" cy="1143000"/>
           </a:xfrm>
         </p:spPr>
         <p:txBody>
@@ -1425,8 +1559,8 @@
         </p:nvSpPr>
         <p:spPr>
           <a:xfrm>
-            <a:off x="457200" y="1600200"/>
-            <a:ext cx="8229600" cy="2185988"/>
+            <a:off x="609600" y="1600200"/>
+            <a:ext cx="10972800" cy="2185988"/>
           </a:xfrm>
         </p:spPr>
         <p:txBody>
@@ -1481,8 +1615,8 @@
         </p:nvSpPr>
         <p:spPr>
           <a:xfrm>
-            <a:off x="457200" y="3938589"/>
-            <a:ext cx="8229600" cy="2187575"/>
+            <a:off x="609600" y="3938589"/>
+            <a:ext cx="10972800" cy="2187575"/>
           </a:xfrm>
         </p:spPr>
         <p:txBody>
@@ -1548,7 +1682,7 @@
           <a:p>
             <a:fld id="{ACD0997E-0CDD-7541-9D88-20A562751868}" type="datetime1">
               <a:rPr lang="en-US" smtClean="0"/>
-              <a:t>10/24/24</a:t>
+              <a:t>10/29/25</a:t>
             </a:fld>
             <a:endParaRPr lang="en-US"/>
           </a:p>
@@ -1650,8 +1784,8 @@
         </p:nvSpPr>
         <p:spPr>
           <a:xfrm>
-            <a:off x="457200" y="274638"/>
-            <a:ext cx="8229600" cy="1143000"/>
+            <a:off x="609600" y="274638"/>
+            <a:ext cx="10972800" cy="1143000"/>
           </a:xfrm>
         </p:spPr>
         <p:txBody>
@@ -1677,8 +1811,8 @@
         </p:nvSpPr>
         <p:spPr>
           <a:xfrm>
-            <a:off x="457200" y="1600204"/>
-            <a:ext cx="4038600" cy="4525963"/>
+            <a:off x="609600" y="1600204"/>
+            <a:ext cx="5384800" cy="4525963"/>
           </a:xfrm>
         </p:spPr>
         <p:txBody>
@@ -1733,8 +1867,8 @@
         </p:nvSpPr>
         <p:spPr>
           <a:xfrm>
-            <a:off x="4648200" y="1600204"/>
-            <a:ext cx="4038600" cy="4525963"/>
+            <a:off x="6197600" y="1600204"/>
+            <a:ext cx="5384800" cy="4525963"/>
           </a:xfrm>
         </p:spPr>
         <p:txBody>
@@ -1800,7 +1934,7 @@
           <a:p>
             <a:fld id="{AC053AD8-5CA7-3F49-B495-B884AFEE8A16}" type="datetime1">
               <a:rPr lang="en-US" smtClean="0"/>
-              <a:t>10/24/24</a:t>
+              <a:t>10/29/25</a:t>
             </a:fld>
             <a:endParaRPr lang="en-US"/>
           </a:p>
@@ -1902,8 +2036,8 @@
         </p:nvSpPr>
         <p:spPr>
           <a:xfrm>
-            <a:off x="457200" y="274638"/>
-            <a:ext cx="8229600" cy="1143000"/>
+            <a:off x="609600" y="274638"/>
+            <a:ext cx="10972800" cy="1143000"/>
           </a:xfrm>
         </p:spPr>
         <p:txBody>
@@ -1929,8 +2063,8 @@
         </p:nvSpPr>
         <p:spPr>
           <a:xfrm>
-            <a:off x="457200" y="1600204"/>
-            <a:ext cx="8229600" cy="4525963"/>
+            <a:off x="609600" y="1600204"/>
+            <a:ext cx="10972800" cy="4525963"/>
           </a:xfrm>
         </p:spPr>
         <p:txBody>
@@ -1969,7 +2103,7 @@
           <a:p>
             <a:fld id="{6C751CFE-5FBC-BA47-8777-CE847435DFFA}" type="datetime1">
               <a:rPr lang="en-US" smtClean="0"/>
-              <a:t>10/24/24</a:t>
+              <a:t>10/29/25</a:t>
             </a:fld>
             <a:endParaRPr lang="en-US"/>
           </a:p>
@@ -2071,8 +2205,8 @@
         </p:nvSpPr>
         <p:spPr>
           <a:xfrm>
-            <a:off x="457200" y="274638"/>
-            <a:ext cx="8229600" cy="1143000"/>
+            <a:off x="609600" y="274638"/>
+            <a:ext cx="10972800" cy="1143000"/>
           </a:xfrm>
         </p:spPr>
         <p:txBody>
@@ -2098,8 +2232,8 @@
         </p:nvSpPr>
         <p:spPr>
           <a:xfrm>
-            <a:off x="457200" y="1600204"/>
-            <a:ext cx="4038600" cy="4525963"/>
+            <a:off x="609600" y="1600204"/>
+            <a:ext cx="5384800" cy="4525963"/>
           </a:xfrm>
         </p:spPr>
         <p:txBody>
@@ -2154,8 +2288,8 @@
         </p:nvSpPr>
         <p:spPr>
           <a:xfrm>
-            <a:off x="4648200" y="1600204"/>
-            <a:ext cx="4038600" cy="4525963"/>
+            <a:off x="6197600" y="1600204"/>
+            <a:ext cx="5384800" cy="4525963"/>
           </a:xfrm>
         </p:spPr>
         <p:txBody>
@@ -2194,7 +2328,7 @@
           <a:p>
             <a:fld id="{7A75583E-7D50-3C4A-8A37-9B3FE7B04D6C}" type="datetime1">
               <a:rPr lang="en-US" smtClean="0"/>
-              <a:t>10/24/24</a:t>
+              <a:t>10/29/25</a:t>
             </a:fld>
             <a:endParaRPr lang="en-US"/>
           </a:p>
@@ -2413,7 +2547,7 @@
         <p:spPr>
           <a:xfrm>
             <a:off x="0" y="6328918"/>
-            <a:ext cx="1396448" cy="785114"/>
+            <a:ext cx="1861931" cy="785114"/>
           </a:xfrm>
           <a:prstGeom prst="rect">
             <a:avLst/>
@@ -2473,7 +2607,7 @@
           <a:p>
             <a:fld id="{EDF769E5-24F5-8F43-8EA5-E948B75DD02E}" type="datetime1">
               <a:rPr lang="en-US" smtClean="0"/>
-              <a:t>10/24/24</a:t>
+              <a:t>10/29/25</a:t>
             </a:fld>
             <a:endParaRPr lang="en-US"/>
           </a:p>
@@ -2549,8 +2683,8 @@
         </p:nvSpPr>
         <p:spPr bwMode="auto">
           <a:xfrm>
-            <a:off x="0" y="1454154"/>
-            <a:ext cx="9144000" cy="1336671"/>
+            <a:off x="0" y="1454155"/>
+            <a:ext cx="12192000" cy="1336671"/>
           </a:xfrm>
           <a:prstGeom prst="rect">
             <a:avLst/>
@@ -2723,7 +2857,7 @@
               <a:buClrTx/>
               <a:buNone/>
             </a:pPr>
-            <a:endParaRPr lang="en-US" kern="0" dirty="0">
+            <a:endParaRPr lang="en-US" sz="3300" kern="0" dirty="0">
               <a:solidFill>
                 <a:schemeClr val="bg1"/>
               </a:solidFill>
@@ -2753,8 +2887,8 @@
         </p:blipFill>
         <p:spPr>
           <a:xfrm>
-            <a:off x="3211995" y="4554495"/>
-            <a:ext cx="2720009" cy="1532272"/>
+            <a:off x="4282661" y="4554495"/>
+            <a:ext cx="3626679" cy="1532272"/>
           </a:xfrm>
           <a:prstGeom prst="rect">
             <a:avLst/>
@@ -2779,8 +2913,8 @@
         </p:nvSpPr>
         <p:spPr>
           <a:xfrm>
-            <a:off x="606357" y="1769441"/>
-            <a:ext cx="3478626" cy="914400"/>
+            <a:off x="808476" y="1769441"/>
+            <a:ext cx="4638168" cy="914400"/>
           </a:xfrm>
         </p:spPr>
         <p:txBody>
@@ -2868,8 +3002,8 @@
         </p:nvSpPr>
         <p:spPr>
           <a:xfrm>
-            <a:off x="457200" y="1600204"/>
-            <a:ext cx="4038600" cy="4525963"/>
+            <a:off x="609600" y="1600204"/>
+            <a:ext cx="5384800" cy="4525963"/>
           </a:xfrm>
         </p:spPr>
         <p:txBody>
@@ -2952,8 +3086,8 @@
         </p:nvSpPr>
         <p:spPr>
           <a:xfrm>
-            <a:off x="4648200" y="1600204"/>
-            <a:ext cx="4038600" cy="4525963"/>
+            <a:off x="6197600" y="1600204"/>
+            <a:ext cx="5384800" cy="4525963"/>
           </a:xfrm>
         </p:spPr>
         <p:txBody>
@@ -3047,7 +3181,7 @@
           <a:p>
             <a:fld id="{8D5B1BC2-7DC9-274F-9AA5-41AD410B73E8}" type="datetime1">
               <a:rPr lang="en-US" smtClean="0"/>
-              <a:t>10/24/24</a:t>
+              <a:t>10/29/25</a:t>
             </a:fld>
             <a:endParaRPr lang="en-US"/>
           </a:p>
@@ -3130,7 +3264,7 @@
         <p:spPr>
           <a:xfrm>
             <a:off x="0" y="6328918"/>
-            <a:ext cx="1396448" cy="785114"/>
+            <a:ext cx="1861931" cy="785114"/>
           </a:xfrm>
           <a:prstGeom prst="rect">
             <a:avLst/>
@@ -3205,8 +3339,8 @@
         </p:nvSpPr>
         <p:spPr>
           <a:xfrm>
-            <a:off x="457200" y="1535113"/>
-            <a:ext cx="4040188" cy="639762"/>
+            <a:off x="609600" y="1535113"/>
+            <a:ext cx="5386917" cy="639762"/>
           </a:xfrm>
         </p:spPr>
         <p:txBody>
@@ -3270,8 +3404,8 @@
         </p:nvSpPr>
         <p:spPr>
           <a:xfrm>
-            <a:off x="457200" y="2174875"/>
-            <a:ext cx="4040188" cy="3951288"/>
+            <a:off x="609600" y="2174875"/>
+            <a:ext cx="5386917" cy="3951288"/>
           </a:xfrm>
         </p:spPr>
         <p:txBody>
@@ -3354,8 +3488,8 @@
         </p:nvSpPr>
         <p:spPr>
           <a:xfrm>
-            <a:off x="4645027" y="1535113"/>
-            <a:ext cx="4041775" cy="639762"/>
+            <a:off x="6193370" y="1535113"/>
+            <a:ext cx="5389033" cy="639762"/>
           </a:xfrm>
         </p:spPr>
         <p:txBody>
@@ -3419,8 +3553,8 @@
         </p:nvSpPr>
         <p:spPr>
           <a:xfrm>
-            <a:off x="4645027" y="2174875"/>
-            <a:ext cx="4041775" cy="3951288"/>
+            <a:off x="6193370" y="2174875"/>
+            <a:ext cx="5389033" cy="3951288"/>
           </a:xfrm>
         </p:spPr>
         <p:txBody>
@@ -3514,7 +3648,7 @@
           <a:p>
             <a:fld id="{B7F9541A-B732-0842-A74F-0C72DB237063}" type="datetime1">
               <a:rPr lang="en-US" smtClean="0"/>
-              <a:t>10/24/24</a:t>
+              <a:t>10/29/25</a:t>
             </a:fld>
             <a:endParaRPr lang="en-US"/>
           </a:p>
@@ -3649,7 +3783,7 @@
           <a:p>
             <a:fld id="{F397BA72-28C9-9A46-8637-8A409BF0CACF}" type="datetime1">
               <a:rPr lang="en-US" smtClean="0"/>
-              <a:t>10/24/24</a:t>
+              <a:t>10/29/25</a:t>
             </a:fld>
             <a:endParaRPr lang="en-US"/>
           </a:p>
@@ -3732,7 +3866,7 @@
         <p:spPr>
           <a:xfrm>
             <a:off x="0" y="6328918"/>
-            <a:ext cx="1396448" cy="785114"/>
+            <a:ext cx="1861931" cy="785114"/>
           </a:xfrm>
           <a:prstGeom prst="rect">
             <a:avLst/>
@@ -3792,7 +3926,7 @@
           <a:p>
             <a:fld id="{C54BA4BC-FC40-B844-8CA3-66DD08AD127A}" type="datetime1">
               <a:rPr lang="en-US" smtClean="0"/>
-              <a:t>10/24/24</a:t>
+              <a:t>10/29/25</a:t>
             </a:fld>
             <a:endParaRPr lang="en-US"/>
           </a:p>
@@ -3894,8 +4028,8 @@
         </p:nvSpPr>
         <p:spPr>
           <a:xfrm>
-            <a:off x="457202" y="273050"/>
-            <a:ext cx="3008313" cy="1162050"/>
+            <a:off x="609603" y="273050"/>
+            <a:ext cx="4011084" cy="1162050"/>
           </a:xfrm>
         </p:spPr>
         <p:txBody>
@@ -3925,8 +4059,8 @@
         </p:nvSpPr>
         <p:spPr>
           <a:xfrm>
-            <a:off x="3575050" y="273052"/>
-            <a:ext cx="5111750" cy="5853113"/>
+            <a:off x="4766733" y="273052"/>
+            <a:ext cx="6815667" cy="5853113"/>
           </a:xfrm>
         </p:spPr>
         <p:txBody>
@@ -4009,8 +4143,8 @@
         </p:nvSpPr>
         <p:spPr>
           <a:xfrm>
-            <a:off x="457202" y="1435102"/>
-            <a:ext cx="3008313" cy="4691063"/>
+            <a:off x="609603" y="1435102"/>
+            <a:ext cx="4011084" cy="4691063"/>
           </a:xfrm>
         </p:spPr>
         <p:txBody>
@@ -4085,7 +4219,7 @@
           <a:p>
             <a:fld id="{A0381634-E977-7043-B341-F77FCA8D6817}" type="datetime1">
               <a:rPr lang="en-US" smtClean="0"/>
-              <a:t>10/24/24</a:t>
+              <a:t>10/29/25</a:t>
             </a:fld>
             <a:endParaRPr lang="en-US"/>
           </a:p>
@@ -4187,8 +4321,8 @@
         </p:nvSpPr>
         <p:spPr>
           <a:xfrm>
-            <a:off x="1792288" y="4800600"/>
-            <a:ext cx="5486400" cy="566738"/>
+            <a:off x="2389717" y="4800600"/>
+            <a:ext cx="7315200" cy="566738"/>
           </a:xfrm>
         </p:spPr>
         <p:txBody>
@@ -4218,8 +4352,8 @@
         </p:nvSpPr>
         <p:spPr>
           <a:xfrm>
-            <a:off x="1792288" y="612775"/>
-            <a:ext cx="5486400" cy="4114800"/>
+            <a:off x="2389717" y="612775"/>
+            <a:ext cx="7315200" cy="4114800"/>
           </a:xfrm>
         </p:spPr>
         <p:txBody>
@@ -4284,8 +4418,8 @@
         </p:nvSpPr>
         <p:spPr>
           <a:xfrm>
-            <a:off x="1792288" y="5367338"/>
-            <a:ext cx="5486400" cy="804862"/>
+            <a:off x="2389717" y="5367338"/>
+            <a:ext cx="7315200" cy="804862"/>
           </a:xfrm>
         </p:spPr>
         <p:txBody>
@@ -4360,7 +4494,7 @@
           <a:p>
             <a:fld id="{C242C96D-D083-B04B-BE8C-D38697A2B148}" type="datetime1">
               <a:rPr lang="en-US" smtClean="0"/>
-              <a:t>10/24/24</a:t>
+              <a:t>10/29/25</a:t>
             </a:fld>
             <a:endParaRPr lang="en-US"/>
           </a:p>
@@ -4467,8 +4601,8 @@
         </p:nvSpPr>
         <p:spPr bwMode="auto">
           <a:xfrm>
-            <a:off x="457200" y="136525"/>
-            <a:ext cx="8229600" cy="729214"/>
+            <a:off x="609600" y="136525"/>
+            <a:ext cx="10972800" cy="729214"/>
           </a:xfrm>
           <a:prstGeom prst="rect">
             <a:avLst/>
@@ -4526,8 +4660,8 @@
         </p:nvSpPr>
         <p:spPr bwMode="auto">
           <a:xfrm>
-            <a:off x="457200" y="1021899"/>
-            <a:ext cx="8229600" cy="4814202"/>
+            <a:off x="609600" y="1021899"/>
+            <a:ext cx="10972800" cy="4814202"/>
           </a:xfrm>
           <a:prstGeom prst="rect">
             <a:avLst/>
@@ -4613,8 +4747,8 @@
         </p:nvSpPr>
         <p:spPr bwMode="auto">
           <a:xfrm>
-            <a:off x="457200" y="6245225"/>
-            <a:ext cx="2133600" cy="476250"/>
+            <a:off x="609600" y="6245225"/>
+            <a:ext cx="2844800" cy="476250"/>
           </a:xfrm>
           <a:prstGeom prst="rect">
             <a:avLst/>
@@ -4650,7 +4784,7 @@
           <a:p>
             <a:fld id="{C3BC7800-B276-A64A-8AB0-19972C98F17B}" type="datetime1">
               <a:rPr lang="en-US" smtClean="0"/>
-              <a:t>10/24/24</a:t>
+              <a:t>10/29/25</a:t>
             </a:fld>
             <a:endParaRPr lang="en-US"/>
           </a:p>
@@ -4668,8 +4802,8 @@
         </p:nvSpPr>
         <p:spPr bwMode="auto">
           <a:xfrm>
-            <a:off x="3124200" y="6245225"/>
-            <a:ext cx="2895600" cy="476250"/>
+            <a:off x="4165600" y="6245225"/>
+            <a:ext cx="3860800" cy="476250"/>
           </a:xfrm>
           <a:prstGeom prst="rect">
             <a:avLst/>
@@ -4719,8 +4853,8 @@
         </p:nvSpPr>
         <p:spPr bwMode="auto">
           <a:xfrm>
-            <a:off x="6553200" y="6245225"/>
-            <a:ext cx="2133600" cy="476250"/>
+            <a:off x="8737600" y="6245225"/>
+            <a:ext cx="2844800" cy="476250"/>
           </a:xfrm>
           <a:prstGeom prst="rect">
             <a:avLst/>
@@ -5240,8 +5374,8 @@
         </p:nvSpPr>
         <p:spPr>
           <a:xfrm>
-            <a:off x="457200" y="1021898"/>
-            <a:ext cx="8356600" cy="5366201"/>
+            <a:off x="1066800" y="879025"/>
+            <a:ext cx="10332720" cy="5659126"/>
           </a:xfrm>
         </p:spPr>
         <p:txBody>
@@ -5257,7 +5391,7 @@
             <a:pPr lvl="1"/>
             <a:r>
               <a:rPr lang="en-US" dirty="0"/>
-              <a:t>What data do you think they used for training?</a:t>
+              <a:t>What population, data do you think they used for training?</a:t>
             </a:r>
           </a:p>
           <a:p>
@@ -5268,16 +5402,32 @@
             </a:r>
           </a:p>
           <a:p>
+            <a:pPr lvl="1"/>
+            <a:endParaRPr lang="en-US" dirty="0"/>
+          </a:p>
+          <a:p>
             <a:r>
               <a:rPr lang="en-US" dirty="0"/>
               <a:t>Do you think it is a good idea to use a model like this to help judges and courts determine criminal sentences? </a:t>
             </a:r>
           </a:p>
           <a:p>
+            <a:pPr marL="0" indent="0">
+              <a:buNone/>
+            </a:pPr>
+            <a:endParaRPr lang="en-US" dirty="0"/>
+          </a:p>
+          <a:p>
             <a:r>
               <a:rPr lang="en-US" dirty="0"/>
-              <a:t>What are the false positives/negatives in this predictive model?  What are the costs of each?  How would you consider going about setting a threshold? </a:t>
-            </a:r>
+              <a:t>What are the false positives/negatives in this predictive model?  What are the costs of each?  Which is worse?  How would you consider going about setting a threshold? </a:t>
+            </a:r>
+          </a:p>
+          <a:p>
+            <a:pPr marL="0" indent="0">
+              <a:buNone/>
+            </a:pPr>
+            <a:endParaRPr lang="en-US" dirty="0"/>
           </a:p>
           <a:p>
             <a:r>
@@ -5289,22 +5439,20 @@
             <a:pPr lvl="1"/>
             <a:r>
               <a:rPr lang="en-US" dirty="0"/>
-              <a:t>How do you think they could have gotten around this? </a:t>
+              <a:t>Do you have thoughts on how to correct for the apparent racial bias?</a:t>
+            </a:r>
+          </a:p>
+          <a:p>
+            <a:pPr lvl="1"/>
+            <a:r>
+              <a:rPr lang="en-US" dirty="0"/>
+              <a:t>Or other thoughts on how to use data science fairly for this particular task? </a:t>
             </a:r>
           </a:p>
           <a:p>
             <a:pPr marL="342900" lvl="1" indent="0">
               <a:buNone/>
             </a:pPr>
-            <a:endParaRPr lang="en-US" dirty="0"/>
-          </a:p>
-          <a:p>
-            <a:r>
-              <a:rPr lang="en-US" dirty="0"/>
-              <a:t>See confusion matrix and calculate accuracy, precision and recall for Black Defendants and for White Defendants.  Do your answers agree with the article? </a:t>
-            </a:r>
-          </a:p>
-          <a:p>
             <a:endParaRPr lang="en-US" dirty="0"/>
           </a:p>
         </p:txBody>
@@ -5352,7 +5500,7 @@
         </p:nvSpPr>
         <p:spPr>
           <a:xfrm>
-            <a:off x="3005959" y="6138041"/>
+            <a:off x="4529960" y="6138041"/>
             <a:ext cx="184731" cy="400110"/>
           </a:xfrm>
           <a:prstGeom prst="rect">
@@ -5366,7 +5514,7 @@
           </a:bodyPr>
           <a:lstStyle/>
           <a:p>
-            <a:pPr marL="0" indent="0" algn="l">
+            <a:pPr>
               <a:buNone/>
             </a:pPr>
             <a:endParaRPr lang="en-US" sz="2000" dirty="0">
@@ -5534,7 +5682,7 @@
                                         <p:tgtEl>
                                           <p:spTgt spid="3">
                                             <p:txEl>
-                                              <p:pRg st="3" end="3"/>
+                                              <p:pRg st="4" end="4"/>
                                             </p:txEl>
                                           </p:spTgt>
                                         </p:tgtEl>
@@ -5583,7 +5731,7 @@
                                         <p:tgtEl>
                                           <p:spTgt spid="3">
                                             <p:txEl>
-                                              <p:pRg st="4" end="4"/>
+                                              <p:pRg st="6" end="6"/>
                                             </p:txEl>
                                           </p:spTgt>
                                         </p:tgtEl>
@@ -5632,7 +5780,7 @@
                                         <p:tgtEl>
                                           <p:spTgt spid="3">
                                             <p:txEl>
-                                              <p:pRg st="5" end="5"/>
+                                              <p:pRg st="8" end="8"/>
                                             </p:txEl>
                                           </p:spTgt>
                                         </p:tgtEl>
@@ -5663,7 +5811,7 @@
                                         <p:tgtEl>
                                           <p:spTgt spid="3">
                                             <p:txEl>
-                                              <p:pRg st="6" end="6"/>
+                                              <p:pRg st="9" end="9"/>
                                             </p:txEl>
                                           </p:spTgt>
                                         </p:tgtEl>
@@ -5678,33 +5826,15 @@
                                   </p:childTnLst>
                                 </p:cTn>
                               </p:par>
-                            </p:childTnLst>
-                          </p:cTn>
-                        </p:par>
-                      </p:childTnLst>
-                    </p:cTn>
-                  </p:par>
-                  <p:par>
-                    <p:cTn id="25" fill="hold">
-                      <p:stCondLst>
-                        <p:cond delay="indefinite"/>
-                      </p:stCondLst>
-                      <p:childTnLst>
-                        <p:par>
-                          <p:cTn id="26" fill="hold">
-                            <p:stCondLst>
-                              <p:cond delay="0"/>
-                            </p:stCondLst>
-                            <p:childTnLst>
                               <p:par>
-                                <p:cTn id="27" presetID="1" presetClass="entr" presetSubtype="0" fill="hold" grpId="0" nodeType="clickEffect">
+                                <p:cTn id="25" presetID="1" presetClass="entr" presetSubtype="0" fill="hold" grpId="0" nodeType="withEffect">
                                   <p:stCondLst>
                                     <p:cond delay="0"/>
                                   </p:stCondLst>
                                   <p:childTnLst>
                                     <p:set>
                                       <p:cBhvr>
-                                        <p:cTn id="28" dur="1" fill="hold">
+                                        <p:cTn id="26" dur="1" fill="hold">
                                           <p:stCondLst>
                                             <p:cond delay="0"/>
                                           </p:stCondLst>
@@ -5712,7 +5842,7 @@
                                         <p:tgtEl>
                                           <p:spTgt spid="3">
                                             <p:txEl>
-                                              <p:pRg st="8" end="8"/>
+                                              <p:pRg st="10" end="10"/>
                                             </p:txEl>
                                           </p:spTgt>
                                         </p:tgtEl>
@@ -5796,7 +5926,7 @@
         </p:nvSpPr>
         <p:spPr>
           <a:xfrm>
-            <a:off x="6565900" y="5889625"/>
+            <a:off x="8089900" y="5889625"/>
             <a:ext cx="2133600" cy="476250"/>
           </a:xfrm>
         </p:spPr>
@@ -5834,7 +5964,7 @@
         </p:blipFill>
         <p:spPr>
           <a:xfrm>
-            <a:off x="-114764" y="397790"/>
+            <a:off x="1378757" y="397790"/>
             <a:ext cx="9373527" cy="5630860"/>
           </a:xfrm>
           <a:prstGeom prst="rect">
@@ -5856,7 +5986,7 @@
         </p:nvSpPr>
         <p:spPr bwMode="auto">
           <a:xfrm>
-            <a:off x="1546787" y="3641170"/>
+            <a:off x="3070788" y="3641170"/>
             <a:ext cx="5603311" cy="280610"/>
           </a:xfrm>
           <a:prstGeom prst="roundRect">
@@ -5884,33 +6014,8 @@
           </a:bodyPr>
           <a:lstStyle/>
           <a:p>
-            <a:pPr marL="342900" marR="0" indent="-342900" algn="l" defTabSz="914400" rtl="0" eaLnBrk="1" fontAlgn="base" latinLnBrk="0" hangingPunct="1">
-              <a:lnSpc>
-                <a:spcPct val="100000"/>
-              </a:lnSpc>
-              <a:spcBef>
-                <a:spcPct val="20000"/>
-              </a:spcBef>
-              <a:spcAft>
-                <a:spcPct val="0"/>
-              </a:spcAft>
-              <a:buClr>
-                <a:srgbClr val="8E0D30"/>
-              </a:buClr>
-              <a:buSzTx/>
-              <a:buFontTx/>
-              <a:buChar char="•"/>
-              <a:tabLst/>
-            </a:pPr>
-            <a:endParaRPr kumimoji="0" lang="en-US" sz="3200" b="0" i="0" u="none" strike="noStrike" cap="none" normalizeH="0" baseline="0">
-              <a:ln>
-                <a:noFill/>
-              </a:ln>
-              <a:solidFill>
-                <a:schemeClr val="tx1"/>
-              </a:solidFill>
-              <a:effectLst/>
-              <a:latin typeface="Times New Roman" pitchFamily="18" charset="0"/>
+            <a:pPr marL="342900" indent="-342900"/>
+            <a:endParaRPr lang="en-US">
               <a:cs typeface="Arial" pitchFamily="34" charset="0"/>
             </a:endParaRPr>
           </a:p>
@@ -5930,7 +6035,7 @@
         </p:nvSpPr>
         <p:spPr bwMode="auto">
           <a:xfrm>
-            <a:off x="1546788" y="3921780"/>
+            <a:off x="3070789" y="3921780"/>
             <a:ext cx="2910911" cy="215544"/>
           </a:xfrm>
           <a:prstGeom prst="roundRect">
@@ -5958,33 +6063,8 @@
           </a:bodyPr>
           <a:lstStyle/>
           <a:p>
-            <a:pPr marL="342900" marR="0" indent="-342900" algn="l" defTabSz="914400" rtl="0" eaLnBrk="1" fontAlgn="base" latinLnBrk="0" hangingPunct="1">
-              <a:lnSpc>
-                <a:spcPct val="100000"/>
-              </a:lnSpc>
-              <a:spcBef>
-                <a:spcPct val="20000"/>
-              </a:spcBef>
-              <a:spcAft>
-                <a:spcPct val="0"/>
-              </a:spcAft>
-              <a:buClr>
-                <a:srgbClr val="8E0D30"/>
-              </a:buClr>
-              <a:buSzTx/>
-              <a:buFontTx/>
-              <a:buChar char="•"/>
-              <a:tabLst/>
-            </a:pPr>
-            <a:endParaRPr kumimoji="0" lang="en-US" sz="3200" b="0" i="0" u="none" strike="noStrike" cap="none" normalizeH="0" baseline="0">
-              <a:ln>
-                <a:noFill/>
-              </a:ln>
-              <a:solidFill>
-                <a:schemeClr val="tx1"/>
-              </a:solidFill>
-              <a:effectLst/>
-              <a:latin typeface="Times New Roman" pitchFamily="18" charset="0"/>
+            <a:pPr marL="342900" indent="-342900"/>
+            <a:endParaRPr lang="en-US">
               <a:cs typeface="Arial" pitchFamily="34" charset="0"/>
             </a:endParaRPr>
           </a:p>
@@ -6004,7 +6084,7 @@
         </p:nvSpPr>
         <p:spPr bwMode="auto">
           <a:xfrm>
-            <a:off x="1478422" y="4144685"/>
+            <a:off x="3002422" y="4144685"/>
             <a:ext cx="5520820" cy="476250"/>
           </a:xfrm>
           <a:prstGeom prst="roundRect">
@@ -6032,33 +6112,8 @@
           </a:bodyPr>
           <a:lstStyle/>
           <a:p>
-            <a:pPr marL="342900" marR="0" indent="-342900" algn="l" defTabSz="914400" rtl="0" eaLnBrk="1" fontAlgn="base" latinLnBrk="0" hangingPunct="1">
-              <a:lnSpc>
-                <a:spcPct val="100000"/>
-              </a:lnSpc>
-              <a:spcBef>
-                <a:spcPct val="20000"/>
-              </a:spcBef>
-              <a:spcAft>
-                <a:spcPct val="0"/>
-              </a:spcAft>
-              <a:buClr>
-                <a:srgbClr val="8E0D30"/>
-              </a:buClr>
-              <a:buSzTx/>
-              <a:buFontTx/>
-              <a:buChar char="•"/>
-              <a:tabLst/>
-            </a:pPr>
-            <a:endParaRPr kumimoji="0" lang="en-US" sz="3200" b="0" i="0" u="none" strike="noStrike" cap="none" normalizeH="0" baseline="0" dirty="0">
-              <a:ln>
-                <a:noFill/>
-              </a:ln>
-              <a:solidFill>
-                <a:schemeClr val="tx1"/>
-              </a:solidFill>
-              <a:effectLst/>
-              <a:latin typeface="Times New Roman" pitchFamily="18" charset="0"/>
+            <a:pPr marL="342900" indent="-342900"/>
+            <a:endParaRPr lang="en-US" dirty="0">
               <a:cs typeface="Arial" pitchFamily="34" charset="0"/>
             </a:endParaRPr>
           </a:p>
@@ -6078,7 +6133,7 @@
         </p:nvSpPr>
         <p:spPr bwMode="auto">
           <a:xfrm>
-            <a:off x="4457700" y="3921780"/>
+            <a:off x="5981700" y="3921781"/>
             <a:ext cx="2541542" cy="222905"/>
           </a:xfrm>
           <a:prstGeom prst="roundRect">
@@ -6106,33 +6161,8 @@
           </a:bodyPr>
           <a:lstStyle/>
           <a:p>
-            <a:pPr marL="342900" marR="0" indent="-342900" algn="l" defTabSz="914400" rtl="0" eaLnBrk="1" fontAlgn="base" latinLnBrk="0" hangingPunct="1">
-              <a:lnSpc>
-                <a:spcPct val="100000"/>
-              </a:lnSpc>
-              <a:spcBef>
-                <a:spcPct val="20000"/>
-              </a:spcBef>
-              <a:spcAft>
-                <a:spcPct val="0"/>
-              </a:spcAft>
-              <a:buClr>
-                <a:srgbClr val="8E0D30"/>
-              </a:buClr>
-              <a:buSzTx/>
-              <a:buFontTx/>
-              <a:buChar char="•"/>
-              <a:tabLst/>
-            </a:pPr>
-            <a:endParaRPr kumimoji="0" lang="en-US" sz="3200" b="0" i="0" u="none" strike="noStrike" cap="none" normalizeH="0" baseline="0" dirty="0">
-              <a:ln>
-                <a:noFill/>
-              </a:ln>
-              <a:solidFill>
-                <a:schemeClr val="tx1"/>
-              </a:solidFill>
-              <a:effectLst/>
-              <a:latin typeface="Times New Roman" pitchFamily="18" charset="0"/>
+            <a:pPr marL="342900" indent="-342900"/>
+            <a:endParaRPr lang="en-US" dirty="0">
               <a:cs typeface="Arial" pitchFamily="34" charset="0"/>
             </a:endParaRPr>
           </a:p>
@@ -6152,7 +6182,7 @@
         </p:nvSpPr>
         <p:spPr bwMode="auto">
           <a:xfrm>
-            <a:off x="4608556" y="3428189"/>
+            <a:off x="6132557" y="3428189"/>
             <a:ext cx="2541543" cy="212982"/>
           </a:xfrm>
           <a:prstGeom prst="roundRect">
@@ -6180,33 +6210,8 @@
           </a:bodyPr>
           <a:lstStyle/>
           <a:p>
-            <a:pPr marL="342900" marR="0" indent="-342900" algn="l" defTabSz="914400" rtl="0" eaLnBrk="1" fontAlgn="base" latinLnBrk="0" hangingPunct="1">
-              <a:lnSpc>
-                <a:spcPct val="100000"/>
-              </a:lnSpc>
-              <a:spcBef>
-                <a:spcPct val="20000"/>
-              </a:spcBef>
-              <a:spcAft>
-                <a:spcPct val="0"/>
-              </a:spcAft>
-              <a:buClr>
-                <a:srgbClr val="8E0D30"/>
-              </a:buClr>
-              <a:buSzTx/>
-              <a:buFontTx/>
-              <a:buChar char="•"/>
-              <a:tabLst/>
-            </a:pPr>
-            <a:endParaRPr kumimoji="0" lang="en-US" sz="3200" b="0" i="0" u="none" strike="noStrike" cap="none" normalizeH="0" baseline="0">
-              <a:ln>
-                <a:noFill/>
-              </a:ln>
-              <a:solidFill>
-                <a:schemeClr val="tx1"/>
-              </a:solidFill>
-              <a:effectLst/>
-              <a:latin typeface="Times New Roman" pitchFamily="18" charset="0"/>
+            <a:pPr marL="342900" indent="-342900"/>
+            <a:endParaRPr lang="en-US">
               <a:cs typeface="Arial" pitchFamily="34" charset="0"/>
             </a:endParaRPr>
           </a:p>
@@ -6226,7 +6231,7 @@
         </p:nvSpPr>
         <p:spPr>
           <a:xfrm>
-            <a:off x="1554412" y="6368866"/>
+            <a:off x="3078412" y="6368866"/>
             <a:ext cx="5588060" cy="342968"/>
           </a:xfrm>
           <a:prstGeom prst="rect">
@@ -6551,6 +6556,212 @@
           </a:p>
         </p:txBody>
       </p:sp>
+      <p:sp>
+        <p:nvSpPr>
+          <p:cNvPr id="3" name="TextBox 2">
+            <a:extLst>
+              <a:ext uri="{FF2B5EF4-FFF2-40B4-BE49-F238E27FC236}">
+                <a16:creationId xmlns:a16="http://schemas.microsoft.com/office/drawing/2014/main" id="{F597332F-8547-5E9D-CB8A-B42900327853}"/>
+              </a:ext>
+            </a:extLst>
+          </p:cNvPr>
+          <p:cNvSpPr txBox="1"/>
+          <p:nvPr/>
+        </p:nvSpPr>
+        <p:spPr>
+          <a:xfrm>
+            <a:off x="3442952" y="309093"/>
+            <a:ext cx="4076437" cy="400110"/>
+          </a:xfrm>
+          <a:prstGeom prst="rect">
+            <a:avLst/>
+          </a:prstGeom>
+          <a:noFill/>
+        </p:spPr>
+        <p:txBody>
+          <a:bodyPr wrap="none" rtlCol="0">
+            <a:spAutoFit/>
+          </a:bodyPr>
+          <a:lstStyle/>
+          <a:p>
+            <a:pPr>
+              <a:buNone/>
+            </a:pPr>
+            <a:r>
+              <a:rPr lang="en-US" sz="2000" dirty="0">
+                <a:latin typeface="Tahoma" panose="020B0604030504040204" pitchFamily="34" charset="0"/>
+                <a:ea typeface="Tahoma" panose="020B0604030504040204" pitchFamily="34" charset="0"/>
+                <a:cs typeface="Tahoma" panose="020B0604030504040204" pitchFamily="34" charset="0"/>
+                <a:hlinkClick r:id="rId2"/>
+              </a:rPr>
+              <a:t>MIT Tech Review – COMPAS game</a:t>
+            </a:r>
+            <a:endParaRPr lang="en-US" sz="2000" dirty="0">
+              <a:latin typeface="Tahoma" panose="020B0604030504040204" pitchFamily="34" charset="0"/>
+              <a:ea typeface="Tahoma" panose="020B0604030504040204" pitchFamily="34" charset="0"/>
+              <a:cs typeface="Tahoma" panose="020B0604030504040204" pitchFamily="34" charset="0"/>
+            </a:endParaRPr>
+          </a:p>
+        </p:txBody>
+      </p:sp>
+      <p:pic>
+        <p:nvPicPr>
+          <p:cNvPr id="5" name="Picture 4" descr="A screen shot of a chart&#10;&#10;AI-generated content may be incorrect.">
+            <a:extLst>
+              <a:ext uri="{FF2B5EF4-FFF2-40B4-BE49-F238E27FC236}">
+                <a16:creationId xmlns:a16="http://schemas.microsoft.com/office/drawing/2014/main" id="{42A876A2-BCDF-567C-6BC9-EC121AA768AE}"/>
+              </a:ext>
+            </a:extLst>
+          </p:cNvPr>
+          <p:cNvPicPr>
+            <a:picLocks noChangeAspect="1"/>
+          </p:cNvPicPr>
+          <p:nvPr/>
+        </p:nvPicPr>
+        <p:blipFill>
+          <a:blip r:embed="rId3"/>
+          <a:stretch>
+            <a:fillRect/>
+          </a:stretch>
+        </p:blipFill>
+        <p:spPr>
+          <a:xfrm>
+            <a:off x="7109086" y="2048257"/>
+            <a:ext cx="3251645" cy="3739895"/>
+          </a:xfrm>
+          <a:prstGeom prst="rect">
+            <a:avLst/>
+          </a:prstGeom>
+        </p:spPr>
+      </p:pic>
+      <p:pic>
+        <p:nvPicPr>
+          <p:cNvPr id="7" name="Picture 6" descr="A screenshot of a news article&#10;&#10;AI-generated content may be incorrect.">
+            <a:extLst>
+              <a:ext uri="{FF2B5EF4-FFF2-40B4-BE49-F238E27FC236}">
+                <a16:creationId xmlns:a16="http://schemas.microsoft.com/office/drawing/2014/main" id="{F9A4A757-AF1A-2E42-11FA-4EB8B341DD8F}"/>
+              </a:ext>
+            </a:extLst>
+          </p:cNvPr>
+          <p:cNvPicPr>
+            <a:picLocks noChangeAspect="1"/>
+          </p:cNvPicPr>
+          <p:nvPr/>
+        </p:nvPicPr>
+        <p:blipFill>
+          <a:blip r:embed="rId4"/>
+          <a:stretch>
+            <a:fillRect/>
+          </a:stretch>
+        </p:blipFill>
+        <p:spPr>
+          <a:xfrm>
+            <a:off x="1524000" y="989547"/>
+            <a:ext cx="5175504" cy="5731928"/>
+          </a:xfrm>
+          <a:prstGeom prst="rect">
+            <a:avLst/>
+          </a:prstGeom>
+        </p:spPr>
+      </p:pic>
+      <p:sp>
+        <p:nvSpPr>
+          <p:cNvPr id="8" name="Rounded Rectangle 7">
+            <a:extLst>
+              <a:ext uri="{FF2B5EF4-FFF2-40B4-BE49-F238E27FC236}">
+                <a16:creationId xmlns:a16="http://schemas.microsoft.com/office/drawing/2014/main" id="{EAE86B64-BEF5-58C9-7415-5D623297FDDE}"/>
+              </a:ext>
+            </a:extLst>
+          </p:cNvPr>
+          <p:cNvSpPr/>
+          <p:nvPr/>
+        </p:nvSpPr>
+        <p:spPr bwMode="auto">
+          <a:xfrm>
+            <a:off x="1650550" y="2931051"/>
+            <a:ext cx="4630277" cy="648728"/>
+          </a:xfrm>
+          <a:prstGeom prst="roundRect">
+            <a:avLst/>
+          </a:prstGeom>
+          <a:solidFill>
+            <a:srgbClr val="FFFF00">
+              <a:alpha val="27059"/>
+            </a:srgbClr>
+          </a:solidFill>
+          <a:ln w="9525" cap="flat" cmpd="sng" algn="ctr">
+            <a:noFill/>
+            <a:prstDash val="solid"/>
+            <a:round/>
+            <a:headEnd type="none" w="med" len="med"/>
+            <a:tailEnd type="none" w="med" len="med"/>
+          </a:ln>
+          <a:effectLst/>
+        </p:spPr>
+        <p:txBody>
+          <a:bodyPr vert="horz" wrap="square" lIns="91440" tIns="45720" rIns="91440" bIns="45720" numCol="1" rtlCol="0" anchor="t" anchorCtr="0" compatLnSpc="1">
+            <a:prstTxWarp prst="textNoShape">
+              <a:avLst/>
+            </a:prstTxWarp>
+          </a:bodyPr>
+          <a:lstStyle/>
+          <a:p>
+            <a:pPr marL="342900" indent="-342900"/>
+            <a:endParaRPr lang="en-US">
+              <a:cs typeface="Arial" pitchFamily="34" charset="0"/>
+            </a:endParaRPr>
+          </a:p>
+        </p:txBody>
+      </p:sp>
+      <p:sp>
+        <p:nvSpPr>
+          <p:cNvPr id="9" name="Rounded Rectangle 8">
+            <a:extLst>
+              <a:ext uri="{FF2B5EF4-FFF2-40B4-BE49-F238E27FC236}">
+                <a16:creationId xmlns:a16="http://schemas.microsoft.com/office/drawing/2014/main" id="{9478216F-0617-D920-8C53-787D0E603ABD}"/>
+              </a:ext>
+            </a:extLst>
+          </p:cNvPr>
+          <p:cNvSpPr/>
+          <p:nvPr/>
+        </p:nvSpPr>
+        <p:spPr bwMode="auto">
+          <a:xfrm>
+            <a:off x="5483158" y="2650441"/>
+            <a:ext cx="797669" cy="280610"/>
+          </a:xfrm>
+          <a:prstGeom prst="roundRect">
+            <a:avLst/>
+          </a:prstGeom>
+          <a:solidFill>
+            <a:srgbClr val="FFFF00">
+              <a:alpha val="27059"/>
+            </a:srgbClr>
+          </a:solidFill>
+          <a:ln w="9525" cap="flat" cmpd="sng" algn="ctr">
+            <a:noFill/>
+            <a:prstDash val="solid"/>
+            <a:round/>
+            <a:headEnd type="none" w="med" len="med"/>
+            <a:tailEnd type="none" w="med" len="med"/>
+          </a:ln>
+          <a:effectLst/>
+        </p:spPr>
+        <p:txBody>
+          <a:bodyPr vert="horz" wrap="square" lIns="91440" tIns="45720" rIns="91440" bIns="45720" numCol="1" rtlCol="0" anchor="t" anchorCtr="0" compatLnSpc="1">
+            <a:prstTxWarp prst="textNoShape">
+              <a:avLst/>
+            </a:prstTxWarp>
+          </a:bodyPr>
+          <a:lstStyle/>
+          <a:p>
+            <a:pPr marL="342900" indent="-342900"/>
+            <a:endParaRPr lang="en-US">
+              <a:cs typeface="Arial" pitchFamily="34" charset="0"/>
+            </a:endParaRPr>
+          </a:p>
+        </p:txBody>
+      </p:sp>
     </p:spTree>
     <p:extLst>
       <p:ext uri="{BB962C8B-B14F-4D97-AF65-F5344CB8AC3E}">
@@ -6561,65 +6772,115 @@
   <p:clrMapOvr>
     <a:masterClrMapping/>
   </p:clrMapOvr>
-</p:sld>
-</file>
-
-<file path=ppt/slides/slide4.xml><?xml version="1.0" encoding="utf-8"?>
-<p:sld xmlns:a="http://schemas.openxmlformats.org/drawingml/2006/main" xmlns:r="http://schemas.openxmlformats.org/officeDocument/2006/relationships" xmlns:p="http://schemas.openxmlformats.org/presentationml/2006/main">
-  <p:cSld>
-    <p:spTree>
-      <p:nvGrpSpPr>
-        <p:cNvPr id="1" name=""/>
-        <p:cNvGrpSpPr/>
-        <p:nvPr/>
-      </p:nvGrpSpPr>
-      <p:grpSpPr>
-        <a:xfrm>
-          <a:off x="0" y="0"/>
-          <a:ext cx="0" cy="0"/>
-          <a:chOff x="0" y="0"/>
-          <a:chExt cx="0" cy="0"/>
-        </a:xfrm>
-      </p:grpSpPr>
-      <p:sp>
-        <p:nvSpPr>
-          <p:cNvPr id="2" name="Slide Number Placeholder 1">
-            <a:extLst>
-              <a:ext uri="{FF2B5EF4-FFF2-40B4-BE49-F238E27FC236}">
-                <a16:creationId xmlns:a16="http://schemas.microsoft.com/office/drawing/2014/main" id="{D128C413-F3BF-94C9-99C4-6F67CFF401B5}"/>
-              </a:ext>
-            </a:extLst>
-          </p:cNvPr>
-          <p:cNvSpPr>
-            <a:spLocks noGrp="1"/>
-          </p:cNvSpPr>
-          <p:nvPr>
-            <p:ph type="sldNum" sz="quarter" idx="12"/>
-          </p:nvPr>
-        </p:nvSpPr>
-        <p:spPr/>
-        <p:txBody>
-          <a:bodyPr/>
-          <a:lstStyle/>
-          <a:p>
-            <a:fld id="{ABBEE3BA-F264-1746-880E-39AD601DF2B1}" type="slidenum">
-              <a:rPr lang="en-US" smtClean="0"/>
-              <a:t>4</a:t>
-            </a:fld>
-            <a:endParaRPr lang="en-US"/>
-          </a:p>
-        </p:txBody>
-      </p:sp>
-    </p:spTree>
-    <p:extLst>
-      <p:ext uri="{BB962C8B-B14F-4D97-AF65-F5344CB8AC3E}">
-        <p14:creationId xmlns:p14="http://schemas.microsoft.com/office/powerpoint/2010/main" val="4173531300"/>
-      </p:ext>
-    </p:extLst>
-  </p:cSld>
-  <p:clrMapOvr>
-    <a:masterClrMapping/>
-  </p:clrMapOvr>
+  <p:timing>
+    <p:tnLst>
+      <p:par>
+        <p:cTn id="1" dur="indefinite" restart="never" nodeType="tmRoot">
+          <p:childTnLst>
+            <p:seq concurrent="1" nextAc="seek">
+              <p:cTn id="2" dur="indefinite" nodeType="mainSeq">
+                <p:childTnLst>
+                  <p:par>
+                    <p:cTn id="3" fill="hold">
+                      <p:stCondLst>
+                        <p:cond delay="indefinite"/>
+                        <p:cond evt="onBegin" delay="0">
+                          <p:tn val="2"/>
+                        </p:cond>
+                      </p:stCondLst>
+                      <p:childTnLst>
+                        <p:par>
+                          <p:cTn id="4" fill="hold">
+                            <p:stCondLst>
+                              <p:cond delay="0"/>
+                            </p:stCondLst>
+                            <p:childTnLst>
+                              <p:par>
+                                <p:cTn id="5" presetID="1" presetClass="entr" presetSubtype="0" fill="hold" grpId="0" nodeType="withEffect">
+                                  <p:stCondLst>
+                                    <p:cond delay="0"/>
+                                  </p:stCondLst>
+                                  <p:childTnLst>
+                                    <p:set>
+                                      <p:cBhvr>
+                                        <p:cTn id="6" dur="1" fill="hold">
+                                          <p:stCondLst>
+                                            <p:cond delay="0"/>
+                                          </p:stCondLst>
+                                        </p:cTn>
+                                        <p:tgtEl>
+                                          <p:spTgt spid="8"/>
+                                        </p:tgtEl>
+                                        <p:attrNameLst>
+                                          <p:attrName>style.visibility</p:attrName>
+                                        </p:attrNameLst>
+                                      </p:cBhvr>
+                                      <p:to>
+                                        <p:strVal val="visible"/>
+                                      </p:to>
+                                    </p:set>
+                                  </p:childTnLst>
+                                </p:cTn>
+                              </p:par>
+                              <p:par>
+                                <p:cTn id="7" presetID="1" presetClass="entr" presetSubtype="0" fill="hold" grpId="0" nodeType="withEffect">
+                                  <p:stCondLst>
+                                    <p:cond delay="0"/>
+                                  </p:stCondLst>
+                                  <p:childTnLst>
+                                    <p:set>
+                                      <p:cBhvr>
+                                        <p:cTn id="8" dur="1" fill="hold">
+                                          <p:stCondLst>
+                                            <p:cond delay="0"/>
+                                          </p:stCondLst>
+                                        </p:cTn>
+                                        <p:tgtEl>
+                                          <p:spTgt spid="9"/>
+                                        </p:tgtEl>
+                                        <p:attrNameLst>
+                                          <p:attrName>style.visibility</p:attrName>
+                                        </p:attrNameLst>
+                                      </p:cBhvr>
+                                      <p:to>
+                                        <p:strVal val="visible"/>
+                                      </p:to>
+                                    </p:set>
+                                  </p:childTnLst>
+                                </p:cTn>
+                              </p:par>
+                            </p:childTnLst>
+                          </p:cTn>
+                        </p:par>
+                      </p:childTnLst>
+                    </p:cTn>
+                  </p:par>
+                </p:childTnLst>
+              </p:cTn>
+              <p:prevCondLst>
+                <p:cond evt="onPrev" delay="0">
+                  <p:tgtEl>
+                    <p:sldTgt/>
+                  </p:tgtEl>
+                </p:cond>
+              </p:prevCondLst>
+              <p:nextCondLst>
+                <p:cond evt="onNext" delay="0">
+                  <p:tgtEl>
+                    <p:sldTgt/>
+                  </p:tgtEl>
+                </p:cond>
+              </p:nextCondLst>
+            </p:seq>
+          </p:childTnLst>
+        </p:cTn>
+      </p:par>
+    </p:tnLst>
+    <p:bldLst>
+      <p:bldP spid="8" grpId="0" animBg="1"/>
+      <p:bldP spid="9" grpId="0" animBg="1"/>
+    </p:bldLst>
+  </p:timing>
 </p:sld>
 </file>
 

</xml_diff>